<commit_message>
Add October 2026 customer complaints to MS Management Report
Co-Authored-By: Claude Opus 5.5 <noreply@anthropic.com>
Claude-Session: https://claude.ai/code/session_01GTmrsdCoiDpDYWrtYopqyP
</commit_message>
<xml_diff>
--- a/OBW_MS_Management_Report_Oct2026.pptx
+++ b/OBW_MS_Management_Report_Oct2026.pptx
@@ -329,151 +329,151 @@
                 <c:formatCode>General</c:formatCode>
                 <c:ptCount val="49"/>
                 <c:pt idx="0">
-                  <c:v>28.0</c:v>
+                  <c:v>28</c:v>
                 </c:pt>
                 <c:pt idx="1">
-                  <c:v>35.0</c:v>
+                  <c:v>35</c:v>
                 </c:pt>
                 <c:pt idx="2">
-                  <c:v>47.0</c:v>
+                  <c:v>47</c:v>
                 </c:pt>
                 <c:pt idx="3">
-                  <c:v>41.0</c:v>
+                  <c:v>41</c:v>
                 </c:pt>
                 <c:pt idx="4">
-                  <c:v>54.0</c:v>
+                  <c:v>54</c:v>
                 </c:pt>
                 <c:pt idx="5">
-                  <c:v>43.0</c:v>
+                  <c:v>43</c:v>
                 </c:pt>
                 <c:pt idx="6">
-                  <c:v>54.0</c:v>
+                  <c:v>54</c:v>
                 </c:pt>
                 <c:pt idx="7">
-                  <c:v>52.0</c:v>
+                  <c:v>52</c:v>
                 </c:pt>
                 <c:pt idx="8">
-                  <c:v>52.0</c:v>
+                  <c:v>52</c:v>
                 </c:pt>
                 <c:pt idx="9">
-                  <c:v>68.0</c:v>
+                  <c:v>68</c:v>
                 </c:pt>
                 <c:pt idx="10">
-                  <c:v>73.0</c:v>
+                  <c:v>73</c:v>
                 </c:pt>
                 <c:pt idx="11">
-                  <c:v>86.0</c:v>
+                  <c:v>86</c:v>
                 </c:pt>
                 <c:pt idx="12">
-                  <c:v>88.0</c:v>
+                  <c:v>88</c:v>
                 </c:pt>
                 <c:pt idx="13">
-                  <c:v>85.0</c:v>
+                  <c:v>85</c:v>
                 </c:pt>
                 <c:pt idx="14">
-                  <c:v>94.0</c:v>
+                  <c:v>94</c:v>
                 </c:pt>
                 <c:pt idx="15">
-                  <c:v>95.0</c:v>
+                  <c:v>95</c:v>
                 </c:pt>
                 <c:pt idx="16">
-                  <c:v>95.0</c:v>
+                  <c:v>95</c:v>
                 </c:pt>
                 <c:pt idx="17">
-                  <c:v>96.0</c:v>
+                  <c:v>96</c:v>
                 </c:pt>
                 <c:pt idx="18">
-                  <c:v>94.0</c:v>
+                  <c:v>94</c:v>
                 </c:pt>
                 <c:pt idx="19">
-                  <c:v>96.0</c:v>
+                  <c:v>96</c:v>
                 </c:pt>
                 <c:pt idx="20">
-                  <c:v>98.0</c:v>
+                  <c:v>98</c:v>
                 </c:pt>
                 <c:pt idx="21">
-                  <c:v>97.0</c:v>
+                  <c:v>97</c:v>
                 </c:pt>
                 <c:pt idx="22">
-                  <c:v>98.0</c:v>
+                  <c:v>98</c:v>
                 </c:pt>
                 <c:pt idx="23">
-                  <c:v>97.0</c:v>
+                  <c:v>97</c:v>
                 </c:pt>
                 <c:pt idx="24">
-                  <c:v>98.0</c:v>
+                  <c:v>98</c:v>
                 </c:pt>
                 <c:pt idx="25">
-                  <c:v>98.0</c:v>
+                  <c:v>98</c:v>
                 </c:pt>
                 <c:pt idx="26">
-                  <c:v>96.0</c:v>
+                  <c:v>96</c:v>
                 </c:pt>
                 <c:pt idx="27">
-                  <c:v>97.0</c:v>
+                  <c:v>97</c:v>
                 </c:pt>
                 <c:pt idx="28">
-                  <c:v>97.0</c:v>
+                  <c:v>97</c:v>
                 </c:pt>
                 <c:pt idx="29">
-                  <c:v>98.0</c:v>
+                  <c:v>98</c:v>
                 </c:pt>
                 <c:pt idx="30">
-                  <c:v>98.0</c:v>
+                  <c:v>98</c:v>
                 </c:pt>
                 <c:pt idx="31">
-                  <c:v>97.0</c:v>
+                  <c:v>97</c:v>
                 </c:pt>
                 <c:pt idx="32">
-                  <c:v>96.0</c:v>
+                  <c:v>96</c:v>
                 </c:pt>
                 <c:pt idx="33">
-                  <c:v>97.0</c:v>
+                  <c:v>97</c:v>
                 </c:pt>
                 <c:pt idx="34">
-                  <c:v>94.0</c:v>
+                  <c:v>94</c:v>
                 </c:pt>
                 <c:pt idx="35">
-                  <c:v>95.0</c:v>
+                  <c:v>95</c:v>
                 </c:pt>
                 <c:pt idx="36">
-                  <c:v>97.0</c:v>
+                  <c:v>97</c:v>
                 </c:pt>
                 <c:pt idx="37">
-                  <c:v>97.0</c:v>
+                  <c:v>97</c:v>
                 </c:pt>
                 <c:pt idx="38">
-                  <c:v>97.0</c:v>
+                  <c:v>97</c:v>
                 </c:pt>
                 <c:pt idx="39">
-                  <c:v>96.0</c:v>
+                  <c:v>96</c:v>
                 </c:pt>
                 <c:pt idx="40">
-                  <c:v>98.0</c:v>
+                  <c:v>98</c:v>
                 </c:pt>
                 <c:pt idx="41">
-                  <c:v>97.0</c:v>
+                  <c:v>97</c:v>
                 </c:pt>
                 <c:pt idx="42">
-                  <c:v>88.0</c:v>
+                  <c:v>88</c:v>
                 </c:pt>
                 <c:pt idx="43">
-                  <c:v>95.0</c:v>
+                  <c:v>95</c:v>
                 </c:pt>
                 <c:pt idx="44">
-                  <c:v>88.0</c:v>
+                  <c:v>88</c:v>
                 </c:pt>
                 <c:pt idx="45">
-                  <c:v>93.0</c:v>
+                  <c:v>93</c:v>
                 </c:pt>
                 <c:pt idx="46">
-                  <c:v>91.0</c:v>
+                  <c:v>91</c:v>
                 </c:pt>
                 <c:pt idx="47">
-                  <c:v>95.0</c:v>
+                  <c:v>95</c:v>
                 </c:pt>
                 <c:pt idx="48">
-                  <c:v>96.0</c:v>
+                  <c:v>96</c:v>
                 </c:pt>
               </c:numCache>
             </c:numRef>
@@ -1344,9 +1344,6 @@
           <a:bodyPr wrap="square" lIns="0" tIns="0" rIns="0" bIns="0" rtlCol="0" anchor="t"/>
           <a:lstStyle/>
           <a:p>
-            <a:pPr marL="0" indent="0">
-              <a:buNone/>
-            </a:pPr>
             <a:r>
               <a:rPr lang="en-US" sz="1200" dirty="0">
                 <a:solidFill>
@@ -1356,7 +1353,7 @@
                 <a:ea typeface="Arial" pitchFamily="34" charset="-122"/>
                 <a:cs typeface="Arial" pitchFamily="34" charset="-120"/>
               </a:rPr>
-              <a:t>October 2026, month to date (1 to 11 Oct)  |  RAN and Core domains</a:t>
+              <a:t>October 2026, cumulative month to date  |  RAN and Core domains</a:t>
             </a:r>
             <a:endParaRPr lang="en-US" sz="1200" dirty="0"/>
           </a:p>
@@ -1412,6 +1409,13 @@
             <a:prstDash val="solid"/>
           </a:ln>
         </p:spPr>
+        <p:txBody>
+          <a:bodyPr/>
+          <a:lstStyle/>
+          <a:p>
+            <a:endParaRPr lang="en-GB"/>
+          </a:p>
+        </p:txBody>
       </p:sp>
       <p:sp>
         <p:nvSpPr>
@@ -1437,6 +1441,13 @@
             <a:prstDash val="solid"/>
           </a:ln>
         </p:spPr>
+        <p:txBody>
+          <a:bodyPr/>
+          <a:lstStyle/>
+          <a:p>
+            <a:endParaRPr lang="en-GB"/>
+          </a:p>
+        </p:txBody>
       </p:sp>
       <p:pic>
         <p:nvPicPr>
@@ -1605,6 +1616,13 @@
             <a:prstDash val="solid"/>
           </a:ln>
         </p:spPr>
+        <p:txBody>
+          <a:bodyPr/>
+          <a:lstStyle/>
+          <a:p>
+            <a:endParaRPr lang="en-GB"/>
+          </a:p>
+        </p:txBody>
       </p:sp>
       <p:sp>
         <p:nvSpPr>
@@ -1630,6 +1648,13 @@
             <a:prstDash val="solid"/>
           </a:ln>
         </p:spPr>
+        <p:txBody>
+          <a:bodyPr/>
+          <a:lstStyle/>
+          <a:p>
+            <a:endParaRPr lang="en-GB"/>
+          </a:p>
+        </p:txBody>
       </p:sp>
       <p:pic>
         <p:nvPicPr>
@@ -1798,6 +1823,13 @@
             <a:prstDash val="solid"/>
           </a:ln>
         </p:spPr>
+        <p:txBody>
+          <a:bodyPr/>
+          <a:lstStyle/>
+          <a:p>
+            <a:endParaRPr lang="en-GB"/>
+          </a:p>
+        </p:txBody>
       </p:sp>
       <p:sp>
         <p:nvSpPr>
@@ -1823,6 +1855,13 @@
             <a:prstDash val="solid"/>
           </a:ln>
         </p:spPr>
+        <p:txBody>
+          <a:bodyPr/>
+          <a:lstStyle/>
+          <a:p>
+            <a:endParaRPr lang="en-GB"/>
+          </a:p>
+        </p:txBody>
       </p:sp>
       <p:pic>
         <p:nvPicPr>
@@ -1991,6 +2030,13 @@
             <a:prstDash val="solid"/>
           </a:ln>
         </p:spPr>
+        <p:txBody>
+          <a:bodyPr/>
+          <a:lstStyle/>
+          <a:p>
+            <a:endParaRPr lang="en-GB"/>
+          </a:p>
+        </p:txBody>
       </p:sp>
       <p:sp>
         <p:nvSpPr>
@@ -2016,6 +2062,13 @@
             <a:prstDash val="solid"/>
           </a:ln>
         </p:spPr>
+        <p:txBody>
+          <a:bodyPr/>
+          <a:lstStyle/>
+          <a:p>
+            <a:endParaRPr lang="en-GB"/>
+          </a:p>
+        </p:txBody>
       </p:sp>
       <p:pic>
         <p:nvPicPr>
@@ -2074,7 +2127,7 @@
                 <a:ea typeface="Arial" pitchFamily="34" charset="-122"/>
                 <a:cs typeface="Arial" pitchFamily="34" charset="-120"/>
               </a:rPr>
-              <a:t>0</a:t>
+              <a:t>2</a:t>
             </a:r>
             <a:endParaRPr lang="en-US" sz="2600" dirty="0"/>
           </a:p>
@@ -2152,7 +2205,7 @@
                 <a:ea typeface="Arial" pitchFamily="34" charset="-122"/>
                 <a:cs typeface="Arial" pitchFamily="34" charset="-120"/>
               </a:rPr>
-              <a:t>No complaint recorded so far</a:t>
+              <a:t>RAN 1  |  Core 1  (both P3)</a:t>
             </a:r>
             <a:endParaRPr lang="en-US" sz="850" dirty="0"/>
           </a:p>
@@ -2184,6 +2237,13 @@
             <a:prstDash val="solid"/>
           </a:ln>
         </p:spPr>
+        <p:txBody>
+          <a:bodyPr/>
+          <a:lstStyle/>
+          <a:p>
+            <a:endParaRPr lang="en-GB"/>
+          </a:p>
+        </p:txBody>
       </p:sp>
       <p:sp>
         <p:nvSpPr>
@@ -2211,6 +2271,13 @@
             <a:prstDash val="solid"/>
           </a:ln>
         </p:spPr>
+        <p:txBody>
+          <a:bodyPr/>
+          <a:lstStyle/>
+          <a:p>
+            <a:endParaRPr lang="en-GB"/>
+          </a:p>
+        </p:txBody>
       </p:sp>
       <p:sp>
         <p:nvSpPr>
@@ -2275,6 +2342,13 @@
             <a:prstDash val="solid"/>
           </a:ln>
         </p:spPr>
+        <p:txBody>
+          <a:bodyPr/>
+          <a:lstStyle/>
+          <a:p>
+            <a:endParaRPr lang="en-GB"/>
+          </a:p>
+        </p:txBody>
       </p:sp>
       <p:sp>
         <p:nvSpPr>
@@ -2339,6 +2413,13 @@
             <a:prstDash val="solid"/>
           </a:ln>
         </p:spPr>
+        <p:txBody>
+          <a:bodyPr/>
+          <a:lstStyle/>
+          <a:p>
+            <a:endParaRPr lang="en-GB"/>
+          </a:p>
+        </p:txBody>
       </p:sp>
       <p:sp>
         <p:nvSpPr>
@@ -2401,6 +2482,13 @@
             <a:prstDash val="solid"/>
           </a:ln>
         </p:spPr>
+        <p:txBody>
+          <a:bodyPr/>
+          <a:lstStyle/>
+          <a:p>
+            <a:endParaRPr lang="en-GB"/>
+          </a:p>
+        </p:txBody>
       </p:sp>
       <p:sp>
         <p:nvSpPr>
@@ -2584,6 +2672,13 @@
             <a:prstDash val="solid"/>
           </a:ln>
         </p:spPr>
+        <p:txBody>
+          <a:bodyPr/>
+          <a:lstStyle/>
+          <a:p>
+            <a:endParaRPr lang="en-GB"/>
+          </a:p>
+        </p:txBody>
       </p:sp>
       <p:sp>
         <p:nvSpPr>
@@ -2726,6 +2821,13 @@
             <a:prstDash val="solid"/>
           </a:ln>
         </p:spPr>
+        <p:txBody>
+          <a:bodyPr/>
+          <a:lstStyle/>
+          <a:p>
+            <a:endParaRPr lang="en-GB"/>
+          </a:p>
+        </p:txBody>
       </p:sp>
       <p:sp>
         <p:nvSpPr>
@@ -2751,6 +2853,13 @@
             <a:prstDash val="solid"/>
           </a:ln>
         </p:spPr>
+        <p:txBody>
+          <a:bodyPr/>
+          <a:lstStyle/>
+          <a:p>
+            <a:endParaRPr lang="en-GB"/>
+          </a:p>
+        </p:txBody>
       </p:sp>
       <p:sp>
         <p:nvSpPr>
@@ -2774,6 +2883,13 @@
             <a:prstDash val="solid"/>
           </a:ln>
         </p:spPr>
+        <p:txBody>
+          <a:bodyPr/>
+          <a:lstStyle/>
+          <a:p>
+            <a:endParaRPr lang="en-GB"/>
+          </a:p>
+        </p:txBody>
       </p:sp>
       <p:sp>
         <p:nvSpPr>
@@ -2879,6 +2995,13 @@
             <a:prstDash val="solid"/>
           </a:ln>
         </p:spPr>
+        <p:txBody>
+          <a:bodyPr/>
+          <a:lstStyle/>
+          <a:p>
+            <a:endParaRPr lang="en-GB"/>
+          </a:p>
+        </p:txBody>
       </p:sp>
       <p:sp>
         <p:nvSpPr>
@@ -3021,6 +3144,13 @@
             <a:prstDash val="solid"/>
           </a:ln>
         </p:spPr>
+        <p:txBody>
+          <a:bodyPr/>
+          <a:lstStyle/>
+          <a:p>
+            <a:endParaRPr lang="en-GB"/>
+          </a:p>
+        </p:txBody>
       </p:sp>
       <p:sp>
         <p:nvSpPr>
@@ -3046,6 +3176,13 @@
             <a:prstDash val="solid"/>
           </a:ln>
         </p:spPr>
+        <p:txBody>
+          <a:bodyPr/>
+          <a:lstStyle/>
+          <a:p>
+            <a:endParaRPr lang="en-GB"/>
+          </a:p>
+        </p:txBody>
       </p:sp>
       <p:sp>
         <p:nvSpPr>
@@ -3069,6 +3206,13 @@
             <a:prstDash val="solid"/>
           </a:ln>
         </p:spPr>
+        <p:txBody>
+          <a:bodyPr/>
+          <a:lstStyle/>
+          <a:p>
+            <a:endParaRPr lang="en-GB"/>
+          </a:p>
+        </p:txBody>
       </p:sp>
       <p:sp>
         <p:nvSpPr>
@@ -3174,6 +3318,13 @@
             <a:prstDash val="solid"/>
           </a:ln>
         </p:spPr>
+        <p:txBody>
+          <a:bodyPr/>
+          <a:lstStyle/>
+          <a:p>
+            <a:endParaRPr lang="en-GB"/>
+          </a:p>
+        </p:txBody>
       </p:sp>
       <p:sp>
         <p:nvSpPr>
@@ -3316,6 +3467,13 @@
             <a:prstDash val="solid"/>
           </a:ln>
         </p:spPr>
+        <p:txBody>
+          <a:bodyPr/>
+          <a:lstStyle/>
+          <a:p>
+            <a:endParaRPr lang="en-GB"/>
+          </a:p>
+        </p:txBody>
       </p:sp>
       <p:sp>
         <p:nvSpPr>
@@ -3341,6 +3499,13 @@
             <a:prstDash val="solid"/>
           </a:ln>
         </p:spPr>
+        <p:txBody>
+          <a:bodyPr/>
+          <a:lstStyle/>
+          <a:p>
+            <a:endParaRPr lang="en-GB"/>
+          </a:p>
+        </p:txBody>
       </p:sp>
       <p:sp>
         <p:nvSpPr>
@@ -3364,6 +3529,13 @@
             <a:prstDash val="solid"/>
           </a:ln>
         </p:spPr>
+        <p:txBody>
+          <a:bodyPr/>
+          <a:lstStyle/>
+          <a:p>
+            <a:endParaRPr lang="en-GB"/>
+          </a:p>
+        </p:txBody>
       </p:sp>
       <p:sp>
         <p:nvSpPr>
@@ -3469,6 +3641,13 @@
             <a:prstDash val="solid"/>
           </a:ln>
         </p:spPr>
+        <p:txBody>
+          <a:bodyPr/>
+          <a:lstStyle/>
+          <a:p>
+            <a:endParaRPr lang="en-GB"/>
+          </a:p>
+        </p:txBody>
       </p:sp>
       <p:sp>
         <p:nvSpPr>
@@ -3611,6 +3790,13 @@
             <a:prstDash val="solid"/>
           </a:ln>
         </p:spPr>
+        <p:txBody>
+          <a:bodyPr/>
+          <a:lstStyle/>
+          <a:p>
+            <a:endParaRPr lang="en-GB"/>
+          </a:p>
+        </p:txBody>
       </p:sp>
       <p:sp>
         <p:nvSpPr>
@@ -3636,6 +3822,13 @@
             <a:prstDash val="solid"/>
           </a:ln>
         </p:spPr>
+        <p:txBody>
+          <a:bodyPr/>
+          <a:lstStyle/>
+          <a:p>
+            <a:endParaRPr lang="en-GB"/>
+          </a:p>
+        </p:txBody>
       </p:sp>
       <p:sp>
         <p:nvSpPr>
@@ -3659,6 +3852,13 @@
             <a:prstDash val="solid"/>
           </a:ln>
         </p:spPr>
+        <p:txBody>
+          <a:bodyPr/>
+          <a:lstStyle/>
+          <a:p>
+            <a:endParaRPr lang="en-GB"/>
+          </a:p>
+        </p:txBody>
       </p:sp>
       <p:sp>
         <p:nvSpPr>
@@ -3881,6 +4081,13 @@
             <a:prstDash val="solid"/>
           </a:ln>
         </p:spPr>
+        <p:txBody>
+          <a:bodyPr/>
+          <a:lstStyle/>
+          <a:p>
+            <a:endParaRPr lang="en-GB"/>
+          </a:p>
+        </p:txBody>
       </p:sp>
       <p:sp>
         <p:nvSpPr>
@@ -4023,6 +4230,13 @@
             <a:prstDash val="solid"/>
           </a:ln>
         </p:spPr>
+        <p:txBody>
+          <a:bodyPr/>
+          <a:lstStyle/>
+          <a:p>
+            <a:endParaRPr lang="en-GB"/>
+          </a:p>
+        </p:txBody>
       </p:sp>
       <p:sp>
         <p:nvSpPr>
@@ -4046,6 +4260,13 @@
             <a:prstDash val="solid"/>
           </a:ln>
         </p:spPr>
+        <p:txBody>
+          <a:bodyPr/>
+          <a:lstStyle/>
+          <a:p>
+            <a:endParaRPr lang="en-GB"/>
+          </a:p>
+        </p:txBody>
       </p:sp>
       <p:sp>
         <p:nvSpPr>
@@ -4151,6 +4372,13 @@
             <a:prstDash val="solid"/>
           </a:ln>
         </p:spPr>
+        <p:txBody>
+          <a:bodyPr/>
+          <a:lstStyle/>
+          <a:p>
+            <a:endParaRPr lang="en-GB"/>
+          </a:p>
+        </p:txBody>
       </p:sp>
       <p:sp>
         <p:nvSpPr>
@@ -4293,6 +4521,13 @@
             <a:prstDash val="solid"/>
           </a:ln>
         </p:spPr>
+        <p:txBody>
+          <a:bodyPr/>
+          <a:lstStyle/>
+          <a:p>
+            <a:endParaRPr lang="en-GB"/>
+          </a:p>
+        </p:txBody>
       </p:sp>
       <p:sp>
         <p:nvSpPr>
@@ -4318,6 +4553,13 @@
             <a:prstDash val="solid"/>
           </a:ln>
         </p:spPr>
+        <p:txBody>
+          <a:bodyPr/>
+          <a:lstStyle/>
+          <a:p>
+            <a:endParaRPr lang="en-GB"/>
+          </a:p>
+        </p:txBody>
       </p:sp>
       <p:sp>
         <p:nvSpPr>
@@ -4341,6 +4583,13 @@
             <a:prstDash val="solid"/>
           </a:ln>
         </p:spPr>
+        <p:txBody>
+          <a:bodyPr/>
+          <a:lstStyle/>
+          <a:p>
+            <a:endParaRPr lang="en-GB"/>
+          </a:p>
+        </p:txBody>
       </p:sp>
       <p:sp>
         <p:nvSpPr>
@@ -4446,6 +4695,13 @@
             <a:prstDash val="solid"/>
           </a:ln>
         </p:spPr>
+        <p:txBody>
+          <a:bodyPr/>
+          <a:lstStyle/>
+          <a:p>
+            <a:endParaRPr lang="en-GB"/>
+          </a:p>
+        </p:txBody>
       </p:sp>
       <p:sp>
         <p:nvSpPr>
@@ -4588,6 +4844,13 @@
             <a:prstDash val="solid"/>
           </a:ln>
         </p:spPr>
+        <p:txBody>
+          <a:bodyPr/>
+          <a:lstStyle/>
+          <a:p>
+            <a:endParaRPr lang="en-GB"/>
+          </a:p>
+        </p:txBody>
       </p:sp>
       <p:sp>
         <p:nvSpPr>
@@ -4613,6 +4876,13 @@
             <a:prstDash val="solid"/>
           </a:ln>
         </p:spPr>
+        <p:txBody>
+          <a:bodyPr/>
+          <a:lstStyle/>
+          <a:p>
+            <a:endParaRPr lang="en-GB"/>
+          </a:p>
+        </p:txBody>
       </p:sp>
       <p:sp>
         <p:nvSpPr>
@@ -4636,6 +4906,13 @@
             <a:prstDash val="solid"/>
           </a:ln>
         </p:spPr>
+        <p:txBody>
+          <a:bodyPr/>
+          <a:lstStyle/>
+          <a:p>
+            <a:endParaRPr lang="en-GB"/>
+          </a:p>
+        </p:txBody>
       </p:sp>
       <p:sp>
         <p:nvSpPr>
@@ -4741,6 +5018,13 @@
             <a:prstDash val="solid"/>
           </a:ln>
         </p:spPr>
+        <p:txBody>
+          <a:bodyPr/>
+          <a:lstStyle/>
+          <a:p>
+            <a:endParaRPr lang="en-GB"/>
+          </a:p>
+        </p:txBody>
       </p:sp>
       <p:sp>
         <p:nvSpPr>
@@ -4883,6 +5167,13 @@
             <a:prstDash val="solid"/>
           </a:ln>
         </p:spPr>
+        <p:txBody>
+          <a:bodyPr/>
+          <a:lstStyle/>
+          <a:p>
+            <a:endParaRPr lang="en-GB"/>
+          </a:p>
+        </p:txBody>
       </p:sp>
       <p:sp>
         <p:nvSpPr>
@@ -4908,6 +5199,13 @@
             <a:prstDash val="solid"/>
           </a:ln>
         </p:spPr>
+        <p:txBody>
+          <a:bodyPr/>
+          <a:lstStyle/>
+          <a:p>
+            <a:endParaRPr lang="en-GB"/>
+          </a:p>
+        </p:txBody>
       </p:sp>
       <p:sp>
         <p:nvSpPr>
@@ -4931,6 +5229,13 @@
             <a:prstDash val="solid"/>
           </a:ln>
         </p:spPr>
+        <p:txBody>
+          <a:bodyPr/>
+          <a:lstStyle/>
+          <a:p>
+            <a:endParaRPr lang="en-GB"/>
+          </a:p>
+        </p:txBody>
       </p:sp>
       <p:sp>
         <p:nvSpPr>
@@ -5032,6 +5337,13 @@
             <a:prstDash val="solid"/>
           </a:ln>
         </p:spPr>
+        <p:txBody>
+          <a:bodyPr/>
+          <a:lstStyle/>
+          <a:p>
+            <a:endParaRPr lang="en-GB"/>
+          </a:p>
+        </p:txBody>
       </p:sp>
       <p:sp>
         <p:nvSpPr>
@@ -5059,6 +5371,13 @@
             <a:prstDash val="solid"/>
           </a:ln>
         </p:spPr>
+        <p:txBody>
+          <a:bodyPr/>
+          <a:lstStyle/>
+          <a:p>
+            <a:endParaRPr lang="en-GB"/>
+          </a:p>
+        </p:txBody>
       </p:sp>
       <p:sp>
         <p:nvSpPr>
@@ -5132,7 +5451,7 @@
                 <a:ea typeface="Arial" pitchFamily="34" charset="-122"/>
                 <a:cs typeface="Arial" pitchFamily="34" charset="-120"/>
               </a:rPr>
-              <a:t>0</a:t>
+              <a:t>100%</a:t>
             </a:r>
             <a:endParaRPr lang="en-US" sz="3600" dirty="0"/>
           </a:p>
@@ -5159,9 +5478,6 @@
           <a:bodyPr wrap="square" lIns="0" tIns="0" rIns="0" bIns="0" rtlCol="0" anchor="t"/>
           <a:lstStyle/>
           <a:p>
-            <a:pPr marL="0" indent="0">
-              <a:buNone/>
-            </a:pPr>
             <a:r>
               <a:rPr lang="en-US" sz="950" dirty="0">
                 <a:solidFill>
@@ -5171,14 +5487,11 @@
                 <a:ea typeface="Arial" pitchFamily="34" charset="-122"/>
                 <a:cs typeface="Arial" pitchFamily="34" charset="-120"/>
               </a:rPr>
-              <a:t>complaints, 1 to 11 Oct</a:t>
+              <a:t>restored within SLA</a:t>
             </a:r>
             <a:endParaRPr lang="en-US" sz="950" dirty="0"/>
           </a:p>
           <a:p>
-            <a:pPr marL="0" indent="0">
-              <a:buNone/>
-            </a:pPr>
             <a:r>
               <a:rPr lang="en-US" sz="950" dirty="0">
                 <a:solidFill>
@@ -5248,15 +5561,22 @@
             <a:avLst/>
           </a:prstGeom>
           <a:solidFill>
-            <a:srgbClr val="2E406A"/>
+            <a:srgbClr val="8FA6C8"/>
           </a:solidFill>
           <a:ln w="12700">
             <a:solidFill>
-              <a:srgbClr val="1A2A4A"/>
+              <a:srgbClr val="8FA6C8"/>
             </a:solidFill>
             <a:prstDash val="solid"/>
           </a:ln>
         </p:spPr>
+        <p:txBody>
+          <a:bodyPr/>
+          <a:lstStyle/>
+          <a:p>
+            <a:endParaRPr lang="en-GB"/>
+          </a:p>
+        </p:txBody>
       </p:sp>
       <p:sp>
         <p:nvSpPr>
@@ -5285,13 +5605,13 @@
             <a:r>
               <a:rPr lang="en-US" sz="900" b="1" dirty="0">
                 <a:solidFill>
-                  <a:srgbClr val="C9D3E3"/>
-                </a:solidFill>
-                <a:latin typeface="Arial" pitchFamily="34" charset="0"/>
-                <a:ea typeface="Arial" pitchFamily="34" charset="-122"/>
-                <a:cs typeface="Arial" pitchFamily="34" charset="-120"/>
-              </a:rPr>
-              <a:t>no complaint</a:t>
+                  <a:srgbClr val="FFFFFF"/>
+                </a:solidFill>
+                <a:latin typeface="Arial" pitchFamily="34" charset="0"/>
+                <a:ea typeface="Arial" pitchFamily="34" charset="-122"/>
+                <a:cs typeface="Arial" pitchFamily="34" charset="-120"/>
+              </a:rPr>
+              <a:t>P3: 1</a:t>
             </a:r>
             <a:endParaRPr lang="en-US" sz="900" dirty="0"/>
           </a:p>
@@ -5330,7 +5650,7 @@
                 <a:ea typeface="Arial" pitchFamily="34" charset="-122"/>
                 <a:cs typeface="Arial" pitchFamily="34" charset="-120"/>
               </a:rPr>
-              <a:t>0</a:t>
+              <a:t>1</a:t>
             </a:r>
             <a:endParaRPr lang="en-US" sz="1100" dirty="0"/>
           </a:p>
@@ -5390,15 +5710,22 @@
             <a:avLst/>
           </a:prstGeom>
           <a:solidFill>
-            <a:srgbClr val="2E406A"/>
+            <a:srgbClr val="8FA6C8"/>
           </a:solidFill>
           <a:ln w="12700">
             <a:solidFill>
-              <a:srgbClr val="1A2A4A"/>
+              <a:srgbClr val="8FA6C8"/>
             </a:solidFill>
             <a:prstDash val="solid"/>
           </a:ln>
         </p:spPr>
+        <p:txBody>
+          <a:bodyPr/>
+          <a:lstStyle/>
+          <a:p>
+            <a:endParaRPr lang="en-GB"/>
+          </a:p>
+        </p:txBody>
       </p:sp>
       <p:sp>
         <p:nvSpPr>
@@ -5427,13 +5754,13 @@
             <a:r>
               <a:rPr lang="en-US" sz="900" b="1" dirty="0">
                 <a:solidFill>
-                  <a:srgbClr val="C9D3E3"/>
-                </a:solidFill>
-                <a:latin typeface="Arial" pitchFamily="34" charset="0"/>
-                <a:ea typeface="Arial" pitchFamily="34" charset="-122"/>
-                <a:cs typeface="Arial" pitchFamily="34" charset="-120"/>
-              </a:rPr>
-              <a:t>no complaint</a:t>
+                  <a:srgbClr val="FFFFFF"/>
+                </a:solidFill>
+                <a:latin typeface="Arial" pitchFamily="34" charset="0"/>
+                <a:ea typeface="Arial" pitchFamily="34" charset="-122"/>
+                <a:cs typeface="Arial" pitchFamily="34" charset="-120"/>
+              </a:rPr>
+              <a:t>P3: 1</a:t>
             </a:r>
             <a:endParaRPr lang="en-US" sz="900" dirty="0"/>
           </a:p>
@@ -5472,7 +5799,7 @@
                 <a:ea typeface="Arial" pitchFamily="34" charset="-122"/>
                 <a:cs typeface="Arial" pitchFamily="34" charset="-120"/>
               </a:rPr>
-              <a:t>0</a:t>
+              <a:t>1</a:t>
             </a:r>
             <a:endParaRPr lang="en-US" sz="1100" dirty="0"/>
           </a:p>
@@ -5567,6 +5894,13 @@
             <a:prstDash val="solid"/>
           </a:ln>
         </p:spPr>
+        <p:txBody>
+          <a:bodyPr/>
+          <a:lstStyle/>
+          <a:p>
+            <a:endParaRPr lang="en-GB"/>
+          </a:p>
+        </p:txBody>
       </p:sp>
       <p:sp>
         <p:nvSpPr>
@@ -6245,6 +6579,13 @@
             <a:prstDash val="solid"/>
           </a:ln>
         </p:spPr>
+        <p:txBody>
+          <a:bodyPr/>
+          <a:lstStyle/>
+          <a:p>
+            <a:endParaRPr lang="en-GB"/>
+          </a:p>
+        </p:txBody>
       </p:sp>
       <p:sp>
         <p:nvSpPr>
@@ -6309,6 +6650,13 @@
             <a:prstDash val="solid"/>
           </a:ln>
         </p:spPr>
+        <p:txBody>
+          <a:bodyPr/>
+          <a:lstStyle/>
+          <a:p>
+            <a:endParaRPr lang="en-GB"/>
+          </a:p>
+        </p:txBody>
       </p:sp>
       <p:sp>
         <p:nvSpPr>
@@ -6453,6 +6801,13 @@
             <a:prstDash val="solid"/>
           </a:ln>
         </p:spPr>
+        <p:txBody>
+          <a:bodyPr/>
+          <a:lstStyle/>
+          <a:p>
+            <a:endParaRPr lang="en-GB"/>
+          </a:p>
+        </p:txBody>
       </p:sp>
       <p:sp>
         <p:nvSpPr>
@@ -6610,7 +6965,7 @@
                 <a:ea typeface="Arial" pitchFamily="34" charset="-122"/>
                 <a:cs typeface="Arial" pitchFamily="34" charset="-120"/>
               </a:rPr>
-              <a:t>Source: OBW daily KPI follow up (incidents and customer complaints), October 2026 cumulative to 11 Oct. YTD volume compares the same weeks of 2025.</a:t>
+              <a:t>Source: OBW daily KPI follow up (incidents and customer complaints), October 2026 cumulative.</a:t>
             </a:r>
             <a:endParaRPr lang="en-US" sz="850" dirty="0"/>
           </a:p>
@@ -6855,6 +7210,13 @@
             <a:prstDash val="solid"/>
           </a:ln>
         </p:spPr>
+        <p:txBody>
+          <a:bodyPr/>
+          <a:lstStyle/>
+          <a:p>
+            <a:endParaRPr lang="en-GB"/>
+          </a:p>
+        </p:txBody>
       </p:sp>
       <p:sp>
         <p:nvSpPr>
@@ -6880,6 +7242,13 @@
             <a:prstDash val="solid"/>
           </a:ln>
         </p:spPr>
+        <p:txBody>
+          <a:bodyPr/>
+          <a:lstStyle/>
+          <a:p>
+            <a:endParaRPr lang="en-GB"/>
+          </a:p>
+        </p:txBody>
       </p:sp>
       <p:pic>
         <p:nvPicPr>
@@ -7048,6 +7417,13 @@
             <a:prstDash val="solid"/>
           </a:ln>
         </p:spPr>
+        <p:txBody>
+          <a:bodyPr/>
+          <a:lstStyle/>
+          <a:p>
+            <a:endParaRPr lang="en-GB"/>
+          </a:p>
+        </p:txBody>
       </p:sp>
       <p:sp>
         <p:nvSpPr>
@@ -7073,6 +7449,13 @@
             <a:prstDash val="solid"/>
           </a:ln>
         </p:spPr>
+        <p:txBody>
+          <a:bodyPr/>
+          <a:lstStyle/>
+          <a:p>
+            <a:endParaRPr lang="en-GB"/>
+          </a:p>
+        </p:txBody>
       </p:sp>
       <p:pic>
         <p:nvPicPr>
@@ -7241,6 +7624,13 @@
             <a:prstDash val="solid"/>
           </a:ln>
         </p:spPr>
+        <p:txBody>
+          <a:bodyPr/>
+          <a:lstStyle/>
+          <a:p>
+            <a:endParaRPr lang="en-GB"/>
+          </a:p>
+        </p:txBody>
       </p:sp>
       <p:sp>
         <p:nvSpPr>
@@ -7266,6 +7656,13 @@
             <a:prstDash val="solid"/>
           </a:ln>
         </p:spPr>
+        <p:txBody>
+          <a:bodyPr/>
+          <a:lstStyle/>
+          <a:p>
+            <a:endParaRPr lang="en-GB"/>
+          </a:p>
+        </p:txBody>
       </p:sp>
       <p:pic>
         <p:nvPicPr>
@@ -7434,6 +7831,13 @@
             <a:prstDash val="solid"/>
           </a:ln>
         </p:spPr>
+        <p:txBody>
+          <a:bodyPr/>
+          <a:lstStyle/>
+          <a:p>
+            <a:endParaRPr lang="en-GB"/>
+          </a:p>
+        </p:txBody>
       </p:sp>
       <p:sp>
         <p:nvSpPr>
@@ -7459,6 +7863,13 @@
             <a:prstDash val="solid"/>
           </a:ln>
         </p:spPr>
+        <p:txBody>
+          <a:bodyPr/>
+          <a:lstStyle/>
+          <a:p>
+            <a:endParaRPr lang="en-GB"/>
+          </a:p>
+        </p:txBody>
       </p:sp>
       <p:pic>
         <p:nvPicPr>
@@ -7469,7 +7880,7 @@
           <p:nvPr/>
         </p:nvPicPr>
         <p:blipFill>
-          <a:blip r:embed="rId14"/>
+          <a:blip r:embed="rId7"/>
           <a:stretch>
             <a:fillRect/>
           </a:stretch>
@@ -7627,6 +8038,13 @@
             <a:prstDash val="solid"/>
           </a:ln>
         </p:spPr>
+        <p:txBody>
+          <a:bodyPr/>
+          <a:lstStyle/>
+          <a:p>
+            <a:endParaRPr lang="en-GB"/>
+          </a:p>
+        </p:txBody>
       </p:sp>
       <p:sp>
         <p:nvSpPr>
@@ -7709,6 +8127,13 @@
             <a:prstDash val="solid"/>
           </a:ln>
         </p:spPr>
+        <p:txBody>
+          <a:bodyPr/>
+          <a:lstStyle/>
+          <a:p>
+            <a:endParaRPr lang="en-GB"/>
+          </a:p>
+        </p:txBody>
       </p:sp>
       <p:sp>
         <p:nvSpPr>
@@ -7775,6 +8200,13 @@
             <a:prstDash val="solid"/>
           </a:ln>
         </p:spPr>
+        <p:txBody>
+          <a:bodyPr/>
+          <a:lstStyle/>
+          <a:p>
+            <a:endParaRPr lang="en-GB"/>
+          </a:p>
+        </p:txBody>
       </p:sp>
       <p:sp>
         <p:nvSpPr>
@@ -7809,7 +8241,7 @@
                 <a:ea typeface="Arial" pitchFamily="34" charset="-122"/>
                 <a:cs typeface="Arial" pitchFamily="34" charset="-120"/>
               </a:rPr>
-              <a:t>Volatility W34 to W38</a:t>
+              <a:t>Volatility W44 to W40</a:t>
             </a:r>
             <a:endParaRPr lang="en-US" sz="800" dirty="0"/>
           </a:p>
@@ -7841,6 +8273,13 @@
             <a:prstDash val="solid"/>
           </a:ln>
         </p:spPr>
+        <p:txBody>
+          <a:bodyPr/>
+          <a:lstStyle/>
+          <a:p>
+            <a:endParaRPr lang="en-GB"/>
+          </a:p>
+        </p:txBody>
       </p:sp>
       <p:sp>
         <p:nvSpPr>
@@ -9930,6 +10369,13 @@
             <a:prstDash val="solid"/>
           </a:ln>
         </p:spPr>
+        <p:txBody>
+          <a:bodyPr/>
+          <a:lstStyle/>
+          <a:p>
+            <a:endParaRPr lang="en-GB"/>
+          </a:p>
+        </p:txBody>
       </p:sp>
       <p:sp>
         <p:nvSpPr>
@@ -10033,6 +10479,13 @@
             <a:prstDash val="solid"/>
           </a:ln>
         </p:spPr>
+        <p:txBody>
+          <a:bodyPr/>
+          <a:lstStyle/>
+          <a:p>
+            <a:endParaRPr lang="en-GB"/>
+          </a:p>
+        </p:txBody>
       </p:sp>
       <p:pic>
         <p:nvPicPr>
@@ -10160,6 +10613,13 @@
             <a:prstDash val="solid"/>
           </a:ln>
         </p:spPr>
+        <p:txBody>
+          <a:bodyPr/>
+          <a:lstStyle/>
+          <a:p>
+            <a:endParaRPr lang="en-GB"/>
+          </a:p>
+        </p:txBody>
       </p:sp>
       <p:pic>
         <p:nvPicPr>
@@ -10287,6 +10747,13 @@
             <a:prstDash val="solid"/>
           </a:ln>
         </p:spPr>
+        <p:txBody>
+          <a:bodyPr/>
+          <a:lstStyle/>
+          <a:p>
+            <a:endParaRPr lang="en-GB"/>
+          </a:p>
+        </p:txBody>
       </p:sp>
       <p:pic>
         <p:nvPicPr>
@@ -10414,6 +10881,13 @@
             <a:prstDash val="solid"/>
           </a:ln>
         </p:spPr>
+        <p:txBody>
+          <a:bodyPr/>
+          <a:lstStyle/>
+          <a:p>
+            <a:endParaRPr lang="en-GB"/>
+          </a:p>
+        </p:txBody>
       </p:sp>
       <p:pic>
         <p:nvPicPr>
@@ -10541,6 +11015,13 @@
             <a:prstDash val="solid"/>
           </a:ln>
         </p:spPr>
+        <p:txBody>
+          <a:bodyPr/>
+          <a:lstStyle/>
+          <a:p>
+            <a:endParaRPr lang="en-GB"/>
+          </a:p>
+        </p:txBody>
       </p:sp>
       <p:pic>
         <p:nvPicPr>

</xml_diff>